<commit_message>
Flyer : trajectoire de puits à la place de l'outil
Co-Authored-By: Claude Sonnet 5.5 <noreply@anthropic.com>
Claude-Session: https://claude.ai/code/session_01XPwnZBmWUGhvYebrP3X3Z2
</commit_message>
<xml_diff>
--- a/flyer_commercial/Flyer_Enedril_A5_EN.pptx
+++ b/flyer_commercial/Flyer_Enedril_A5_EN.pptx
@@ -3284,9 +3284,755 @@
           </a:p>
         </p:txBody>
       </p:sp>
+      <p:sp>
+        <p:nvSpPr>
+          <p:cNvPr id="5" name="Freeform 4"/>
+          <p:cNvSpPr/>
+          <p:nvPr/>
+        </p:nvSpPr>
+        <p:spPr>
+          <a:xfrm>
+            <a:off x="889000" y="431800"/>
+            <a:ext cx="3149600" cy="2171700"/>
+          </a:xfrm>
+          <a:custGeom>
+            <a:avLst/>
+            <a:gdLst/>
+            <a:ahLst/>
+            <a:cxnLst/>
+            <a:rect l="l" t="t" r="r" b="b"/>
+            <a:pathLst>
+              <a:path w="3149600" h="2171700">
+                <a:moveTo>
+                  <a:pt x="3149600" y="0"/>
+                </a:moveTo>
+                <a:lnTo>
+                  <a:pt x="3148725" y="71786"/>
+                </a:lnTo>
+                <a:lnTo>
+                  <a:pt x="3146100" y="142366"/>
+                </a:lnTo>
+                <a:lnTo>
+                  <a:pt x="3141726" y="211740"/>
+                </a:lnTo>
+                <a:lnTo>
+                  <a:pt x="3135601" y="279908"/>
+                </a:lnTo>
+                <a:lnTo>
+                  <a:pt x="3127727" y="346868"/>
+                </a:lnTo>
+                <a:lnTo>
+                  <a:pt x="3118104" y="412623"/>
+                </a:lnTo>
+                <a:lnTo>
+                  <a:pt x="3106730" y="477170"/>
+                </a:lnTo>
+                <a:lnTo>
+                  <a:pt x="3093607" y="540512"/>
+                </a:lnTo>
+                <a:lnTo>
+                  <a:pt x="3078733" y="602646"/>
+                </a:lnTo>
+                <a:lnTo>
+                  <a:pt x="3062111" y="663575"/>
+                </a:lnTo>
+                <a:lnTo>
+                  <a:pt x="3043738" y="723296"/>
+                </a:lnTo>
+                <a:lnTo>
+                  <a:pt x="3023616" y="781812"/>
+                </a:lnTo>
+                <a:lnTo>
+                  <a:pt x="3001743" y="839120"/>
+                </a:lnTo>
+                <a:lnTo>
+                  <a:pt x="2978121" y="895223"/>
+                </a:lnTo>
+                <a:lnTo>
+                  <a:pt x="2952750" y="950118"/>
+                </a:lnTo>
+                <a:lnTo>
+                  <a:pt x="2925628" y="1003808"/>
+                </a:lnTo>
+                <a:lnTo>
+                  <a:pt x="2896757" y="1056290"/>
+                </a:lnTo>
+                <a:lnTo>
+                  <a:pt x="2866136" y="1107567"/>
+                </a:lnTo>
+                <a:lnTo>
+                  <a:pt x="2833765" y="1157636"/>
+                </a:lnTo>
+                <a:lnTo>
+                  <a:pt x="2799644" y="1206500"/>
+                </a:lnTo>
+                <a:lnTo>
+                  <a:pt x="2763774" y="1254156"/>
+                </a:lnTo>
+                <a:lnTo>
+                  <a:pt x="2726153" y="1300606"/>
+                </a:lnTo>
+                <a:lnTo>
+                  <a:pt x="2686783" y="1345850"/>
+                </a:lnTo>
+                <a:lnTo>
+                  <a:pt x="2645664" y="1389888"/>
+                </a:lnTo>
+                <a:lnTo>
+                  <a:pt x="2602794" y="1432718"/>
+                </a:lnTo>
+                <a:lnTo>
+                  <a:pt x="2558175" y="1474343"/>
+                </a:lnTo>
+                <a:lnTo>
+                  <a:pt x="2511806" y="1514760"/>
+                </a:lnTo>
+                <a:lnTo>
+                  <a:pt x="2463687" y="1553972"/>
+                </a:lnTo>
+                <a:lnTo>
+                  <a:pt x="2413818" y="1591976"/>
+                </a:lnTo>
+                <a:lnTo>
+                  <a:pt x="2362200" y="1628775"/>
+                </a:lnTo>
+                <a:lnTo>
+                  <a:pt x="2308831" y="1664366"/>
+                </a:lnTo>
+                <a:lnTo>
+                  <a:pt x="2253713" y="1698752"/>
+                </a:lnTo>
+                <a:lnTo>
+                  <a:pt x="2196846" y="1731930"/>
+                </a:lnTo>
+                <a:lnTo>
+                  <a:pt x="2138228" y="1763903"/>
+                </a:lnTo>
+                <a:lnTo>
+                  <a:pt x="2077861" y="1794668"/>
+                </a:lnTo>
+                <a:lnTo>
+                  <a:pt x="2015743" y="1824228"/>
+                </a:lnTo>
+                <a:lnTo>
+                  <a:pt x="1951877" y="1852580"/>
+                </a:lnTo>
+                <a:lnTo>
+                  <a:pt x="1886260" y="1879727"/>
+                </a:lnTo>
+                <a:lnTo>
+                  <a:pt x="1818893" y="1905666"/>
+                </a:lnTo>
+                <a:lnTo>
+                  <a:pt x="1749777" y="1930400"/>
+                </a:lnTo>
+                <a:lnTo>
+                  <a:pt x="1678911" y="1953926"/>
+                </a:lnTo>
+                <a:lnTo>
+                  <a:pt x="1606296" y="1976247"/>
+                </a:lnTo>
+                <a:lnTo>
+                  <a:pt x="1531930" y="1997360"/>
+                </a:lnTo>
+                <a:lnTo>
+                  <a:pt x="1455815" y="2017267"/>
+                </a:lnTo>
+                <a:lnTo>
+                  <a:pt x="1377950" y="2035968"/>
+                </a:lnTo>
+                <a:lnTo>
+                  <a:pt x="1298335" y="2053463"/>
+                </a:lnTo>
+                <a:lnTo>
+                  <a:pt x="1216970" y="2069750"/>
+                </a:lnTo>
+                <a:lnTo>
+                  <a:pt x="1133856" y="2084832"/>
+                </a:lnTo>
+                <a:lnTo>
+                  <a:pt x="1048991" y="2098706"/>
+                </a:lnTo>
+                <a:lnTo>
+                  <a:pt x="962377" y="2111375"/>
+                </a:lnTo>
+                <a:lnTo>
+                  <a:pt x="874014" y="2122836"/>
+                </a:lnTo>
+                <a:lnTo>
+                  <a:pt x="783900" y="2133092"/>
+                </a:lnTo>
+                <a:lnTo>
+                  <a:pt x="692037" y="2142140"/>
+                </a:lnTo>
+                <a:lnTo>
+                  <a:pt x="598423" y="2149983"/>
+                </a:lnTo>
+                <a:lnTo>
+                  <a:pt x="503061" y="2156618"/>
+                </a:lnTo>
+                <a:lnTo>
+                  <a:pt x="405948" y="2162048"/>
+                </a:lnTo>
+                <a:lnTo>
+                  <a:pt x="307086" y="2166270"/>
+                </a:lnTo>
+                <a:lnTo>
+                  <a:pt x="206473" y="2169287"/>
+                </a:lnTo>
+                <a:lnTo>
+                  <a:pt x="104111" y="2171096"/>
+                </a:lnTo>
+                <a:lnTo>
+                  <a:pt x="0" y="2171700"/>
+                </a:lnTo>
+              </a:path>
+            </a:pathLst>
+          </a:custGeom>
+          <a:noFill/>
+          <a:ln w="38100">
+            <a:solidFill>
+              <a:srgbClr val="1CB2FE"/>
+            </a:solidFill>
+          </a:ln>
+          <a:effectLst/>
+        </p:spPr>
+        <p:style>
+          <a:lnRef idx="1">
+            <a:schemeClr val="accent1"/>
+          </a:lnRef>
+          <a:fillRef idx="3">
+            <a:schemeClr val="accent1"/>
+          </a:fillRef>
+          <a:effectRef idx="2">
+            <a:schemeClr val="accent1"/>
+          </a:effectRef>
+          <a:fontRef idx="minor">
+            <a:schemeClr val="lt1"/>
+          </a:fontRef>
+        </p:style>
+        <p:txBody>
+          <a:bodyPr rtlCol="0" anchor="ctr"/>
+          <a:lstStyle/>
+          <a:p>
+            <a:pPr algn="ctr"/>
+          </a:p>
+        </p:txBody>
+      </p:sp>
+      <p:sp>
+        <p:nvSpPr>
+          <p:cNvPr id="6" name="Oval 5"/>
+          <p:cNvSpPr/>
+          <p:nvPr/>
+        </p:nvSpPr>
+        <p:spPr>
+          <a:xfrm>
+            <a:off x="800100" y="2514600"/>
+            <a:ext cx="177800" cy="177800"/>
+          </a:xfrm>
+          <a:prstGeom prst="ellipse">
+            <a:avLst/>
+          </a:prstGeom>
+          <a:solidFill>
+            <a:srgbClr val="08203F"/>
+          </a:solidFill>
+          <a:ln w="31750">
+            <a:solidFill>
+              <a:srgbClr val="1CB2FE"/>
+            </a:solidFill>
+          </a:ln>
+          <a:effectLst/>
+        </p:spPr>
+        <p:style>
+          <a:lnRef idx="1">
+            <a:schemeClr val="accent1"/>
+          </a:lnRef>
+          <a:fillRef idx="3">
+            <a:schemeClr val="accent1"/>
+          </a:fillRef>
+          <a:effectRef idx="2">
+            <a:schemeClr val="accent1"/>
+          </a:effectRef>
+          <a:fontRef idx="minor">
+            <a:schemeClr val="lt1"/>
+          </a:fontRef>
+        </p:style>
+        <p:txBody>
+          <a:bodyPr rtlCol="0" anchor="ctr"/>
+          <a:lstStyle/>
+          <a:p>
+            <a:pPr algn="ctr"/>
+          </a:p>
+        </p:txBody>
+      </p:sp>
+      <p:sp>
+        <p:nvSpPr>
+          <p:cNvPr id="7" name="Freeform 6"/>
+          <p:cNvSpPr/>
+          <p:nvPr/>
+        </p:nvSpPr>
+        <p:spPr>
+          <a:xfrm>
+            <a:off x="4724400" y="431800"/>
+            <a:ext cx="15240" cy="2184400"/>
+          </a:xfrm>
+          <a:custGeom>
+            <a:avLst/>
+            <a:gdLst/>
+            <a:ahLst/>
+            <a:cxnLst/>
+            <a:rect l="l" t="t" r="r" b="b"/>
+            <a:pathLst>
+              <a:path w="15240" h="2184400">
+                <a:moveTo>
+                  <a:pt x="0" y="0"/>
+                </a:moveTo>
+                <a:lnTo>
+                  <a:pt x="15240" y="0"/>
+                </a:lnTo>
+                <a:lnTo>
+                  <a:pt x="15240" y="2184400"/>
+                </a:lnTo>
+                <a:lnTo>
+                  <a:pt x="0" y="2184400"/>
+                </a:lnTo>
+                <a:close/>
+              </a:path>
+            </a:pathLst>
+          </a:custGeom>
+          <a:solidFill>
+            <a:srgbClr val="3C64A0"/>
+          </a:solidFill>
+          <a:ln>
+            <a:noFill/>
+          </a:ln>
+          <a:effectLst/>
+        </p:spPr>
+        <p:style>
+          <a:lnRef idx="1">
+            <a:schemeClr val="accent1"/>
+          </a:lnRef>
+          <a:fillRef idx="3">
+            <a:schemeClr val="accent1"/>
+          </a:fillRef>
+          <a:effectRef idx="2">
+            <a:schemeClr val="accent1"/>
+          </a:effectRef>
+          <a:fontRef idx="minor">
+            <a:schemeClr val="lt1"/>
+          </a:fontRef>
+        </p:style>
+        <p:txBody>
+          <a:bodyPr rtlCol="0" anchor="ctr"/>
+          <a:lstStyle/>
+          <a:p>
+            <a:pPr algn="ctr"/>
+          </a:p>
+        </p:txBody>
+      </p:sp>
+      <p:sp>
+        <p:nvSpPr>
+          <p:cNvPr id="8" name="Freeform 7"/>
+          <p:cNvSpPr/>
+          <p:nvPr/>
+        </p:nvSpPr>
+        <p:spPr>
+          <a:xfrm>
+            <a:off x="4648200" y="431800"/>
+            <a:ext cx="177800" cy="15240"/>
+          </a:xfrm>
+          <a:custGeom>
+            <a:avLst/>
+            <a:gdLst/>
+            <a:ahLst/>
+            <a:cxnLst/>
+            <a:rect l="l" t="t" r="r" b="b"/>
+            <a:pathLst>
+              <a:path w="177800" h="15240">
+                <a:moveTo>
+                  <a:pt x="0" y="0"/>
+                </a:moveTo>
+                <a:lnTo>
+                  <a:pt x="177800" y="0"/>
+                </a:lnTo>
+                <a:lnTo>
+                  <a:pt x="177800" y="15240"/>
+                </a:lnTo>
+                <a:lnTo>
+                  <a:pt x="0" y="15240"/>
+                </a:lnTo>
+                <a:close/>
+              </a:path>
+            </a:pathLst>
+          </a:custGeom>
+          <a:solidFill>
+            <a:srgbClr val="82AFE6"/>
+          </a:solidFill>
+          <a:ln>
+            <a:noFill/>
+          </a:ln>
+          <a:effectLst/>
+        </p:spPr>
+        <p:style>
+          <a:lnRef idx="1">
+            <a:schemeClr val="accent1"/>
+          </a:lnRef>
+          <a:fillRef idx="3">
+            <a:schemeClr val="accent1"/>
+          </a:fillRef>
+          <a:effectRef idx="2">
+            <a:schemeClr val="accent1"/>
+          </a:effectRef>
+          <a:fontRef idx="minor">
+            <a:schemeClr val="lt1"/>
+          </a:fontRef>
+        </p:style>
+        <p:txBody>
+          <a:bodyPr rtlCol="0" anchor="ctr"/>
+          <a:lstStyle/>
+          <a:p>
+            <a:pPr algn="ctr"/>
+          </a:p>
+        </p:txBody>
+      </p:sp>
+      <p:sp>
+        <p:nvSpPr>
+          <p:cNvPr id="9" name="TextBox 8"/>
+          <p:cNvSpPr txBox="1"/>
+          <p:nvPr/>
+        </p:nvSpPr>
+        <p:spPr>
+          <a:xfrm>
+            <a:off x="3759200" y="368300"/>
+            <a:ext cx="838200" cy="127000"/>
+          </a:xfrm>
+          <a:prstGeom prst="rect">
+            <a:avLst/>
+          </a:prstGeom>
+          <a:noFill/>
+        </p:spPr>
+        <p:txBody>
+          <a:bodyPr wrap="square" anchor="t" lIns="0" rIns="0" tIns="0" bIns="0">
+            <a:spAutoFit/>
+          </a:bodyPr>
+          <a:lstStyle/>
+          <a:p>
+            <a:pPr algn="r"/>
+            <a:r>
+              <a:rPr sz="700" b="0">
+                <a:solidFill>
+                  <a:srgbClr val="96BEEB"/>
+                </a:solidFill>
+                <a:latin typeface="Ubuntu Mono"/>
+              </a:rPr>
+              <a:t>0</a:t>
+            </a:r>
+          </a:p>
+        </p:txBody>
+      </p:sp>
+      <p:sp>
+        <p:nvSpPr>
+          <p:cNvPr id="10" name="Freeform 9"/>
+          <p:cNvSpPr/>
+          <p:nvPr/>
+        </p:nvSpPr>
+        <p:spPr>
+          <a:xfrm>
+            <a:off x="4648200" y="1159510"/>
+            <a:ext cx="177800" cy="15240"/>
+          </a:xfrm>
+          <a:custGeom>
+            <a:avLst/>
+            <a:gdLst/>
+            <a:ahLst/>
+            <a:cxnLst/>
+            <a:rect l="l" t="t" r="r" b="b"/>
+            <a:pathLst>
+              <a:path w="177800" h="15240">
+                <a:moveTo>
+                  <a:pt x="0" y="0"/>
+                </a:moveTo>
+                <a:lnTo>
+                  <a:pt x="177800" y="0"/>
+                </a:lnTo>
+                <a:lnTo>
+                  <a:pt x="177800" y="15240"/>
+                </a:lnTo>
+                <a:lnTo>
+                  <a:pt x="0" y="15240"/>
+                </a:lnTo>
+                <a:close/>
+              </a:path>
+            </a:pathLst>
+          </a:custGeom>
+          <a:solidFill>
+            <a:srgbClr val="82AFE6"/>
+          </a:solidFill>
+          <a:ln>
+            <a:noFill/>
+          </a:ln>
+          <a:effectLst/>
+        </p:spPr>
+        <p:style>
+          <a:lnRef idx="1">
+            <a:schemeClr val="accent1"/>
+          </a:lnRef>
+          <a:fillRef idx="3">
+            <a:schemeClr val="accent1"/>
+          </a:fillRef>
+          <a:effectRef idx="2">
+            <a:schemeClr val="accent1"/>
+          </a:effectRef>
+          <a:fontRef idx="minor">
+            <a:schemeClr val="lt1"/>
+          </a:fontRef>
+        </p:style>
+        <p:txBody>
+          <a:bodyPr rtlCol="0" anchor="ctr"/>
+          <a:lstStyle/>
+          <a:p>
+            <a:pPr algn="ctr"/>
+          </a:p>
+        </p:txBody>
+      </p:sp>
+      <p:sp>
+        <p:nvSpPr>
+          <p:cNvPr id="11" name="TextBox 10"/>
+          <p:cNvSpPr txBox="1"/>
+          <p:nvPr/>
+        </p:nvSpPr>
+        <p:spPr>
+          <a:xfrm>
+            <a:off x="3759200" y="1096010"/>
+            <a:ext cx="838200" cy="127000"/>
+          </a:xfrm>
+          <a:prstGeom prst="rect">
+            <a:avLst/>
+          </a:prstGeom>
+          <a:noFill/>
+        </p:spPr>
+        <p:txBody>
+          <a:bodyPr wrap="square" anchor="t" lIns="0" rIns="0" tIns="0" bIns="0">
+            <a:spAutoFit/>
+          </a:bodyPr>
+          <a:lstStyle/>
+          <a:p>
+            <a:pPr algn="r"/>
+            <a:r>
+              <a:rPr sz="700" b="0">
+                <a:solidFill>
+                  <a:srgbClr val="96BEEB"/>
+                </a:solidFill>
+                <a:latin typeface="Ubuntu Mono"/>
+              </a:rPr>
+              <a:t>1 000 m</a:t>
+            </a:r>
+          </a:p>
+        </p:txBody>
+      </p:sp>
+      <p:sp>
+        <p:nvSpPr>
+          <p:cNvPr id="12" name="Freeform 11"/>
+          <p:cNvSpPr/>
+          <p:nvPr/>
+        </p:nvSpPr>
+        <p:spPr>
+          <a:xfrm>
+            <a:off x="4648200" y="1887220"/>
+            <a:ext cx="177800" cy="15239"/>
+          </a:xfrm>
+          <a:custGeom>
+            <a:avLst/>
+            <a:gdLst/>
+            <a:ahLst/>
+            <a:cxnLst/>
+            <a:rect l="l" t="t" r="r" b="b"/>
+            <a:pathLst>
+              <a:path w="177800" h="15239">
+                <a:moveTo>
+                  <a:pt x="0" y="0"/>
+                </a:moveTo>
+                <a:lnTo>
+                  <a:pt x="177800" y="0"/>
+                </a:lnTo>
+                <a:lnTo>
+                  <a:pt x="177800" y="15239"/>
+                </a:lnTo>
+                <a:lnTo>
+                  <a:pt x="0" y="15239"/>
+                </a:lnTo>
+                <a:close/>
+              </a:path>
+            </a:pathLst>
+          </a:custGeom>
+          <a:solidFill>
+            <a:srgbClr val="82AFE6"/>
+          </a:solidFill>
+          <a:ln>
+            <a:noFill/>
+          </a:ln>
+          <a:effectLst/>
+        </p:spPr>
+        <p:style>
+          <a:lnRef idx="1">
+            <a:schemeClr val="accent1"/>
+          </a:lnRef>
+          <a:fillRef idx="3">
+            <a:schemeClr val="accent1"/>
+          </a:fillRef>
+          <a:effectRef idx="2">
+            <a:schemeClr val="accent1"/>
+          </a:effectRef>
+          <a:fontRef idx="minor">
+            <a:schemeClr val="lt1"/>
+          </a:fontRef>
+        </p:style>
+        <p:txBody>
+          <a:bodyPr rtlCol="0" anchor="ctr"/>
+          <a:lstStyle/>
+          <a:p>
+            <a:pPr algn="ctr"/>
+          </a:p>
+        </p:txBody>
+      </p:sp>
+      <p:sp>
+        <p:nvSpPr>
+          <p:cNvPr id="13" name="TextBox 12"/>
+          <p:cNvSpPr txBox="1"/>
+          <p:nvPr/>
+        </p:nvSpPr>
+        <p:spPr>
+          <a:xfrm>
+            <a:off x="3759200" y="1823720"/>
+            <a:ext cx="838200" cy="127000"/>
+          </a:xfrm>
+          <a:prstGeom prst="rect">
+            <a:avLst/>
+          </a:prstGeom>
+          <a:noFill/>
+        </p:spPr>
+        <p:txBody>
+          <a:bodyPr wrap="square" anchor="t" lIns="0" rIns="0" tIns="0" bIns="0">
+            <a:spAutoFit/>
+          </a:bodyPr>
+          <a:lstStyle/>
+          <a:p>
+            <a:pPr algn="r"/>
+            <a:r>
+              <a:rPr sz="700" b="0">
+                <a:solidFill>
+                  <a:srgbClr val="96BEEB"/>
+                </a:solidFill>
+                <a:latin typeface="Ubuntu Mono"/>
+              </a:rPr>
+              <a:t>2 000 m</a:t>
+            </a:r>
+          </a:p>
+        </p:txBody>
+      </p:sp>
+      <p:sp>
+        <p:nvSpPr>
+          <p:cNvPr id="14" name="Freeform 13"/>
+          <p:cNvSpPr/>
+          <p:nvPr/>
+        </p:nvSpPr>
+        <p:spPr>
+          <a:xfrm>
+            <a:off x="4648200" y="2614929"/>
+            <a:ext cx="177800" cy="15240"/>
+          </a:xfrm>
+          <a:custGeom>
+            <a:avLst/>
+            <a:gdLst/>
+            <a:ahLst/>
+            <a:cxnLst/>
+            <a:rect l="l" t="t" r="r" b="b"/>
+            <a:pathLst>
+              <a:path w="177800" h="15240">
+                <a:moveTo>
+                  <a:pt x="0" y="0"/>
+                </a:moveTo>
+                <a:lnTo>
+                  <a:pt x="177800" y="0"/>
+                </a:lnTo>
+                <a:lnTo>
+                  <a:pt x="177800" y="15240"/>
+                </a:lnTo>
+                <a:lnTo>
+                  <a:pt x="0" y="15240"/>
+                </a:lnTo>
+                <a:close/>
+              </a:path>
+            </a:pathLst>
+          </a:custGeom>
+          <a:solidFill>
+            <a:srgbClr val="82AFE6"/>
+          </a:solidFill>
+          <a:ln>
+            <a:noFill/>
+          </a:ln>
+          <a:effectLst/>
+        </p:spPr>
+        <p:style>
+          <a:lnRef idx="1">
+            <a:schemeClr val="accent1"/>
+          </a:lnRef>
+          <a:fillRef idx="3">
+            <a:schemeClr val="accent1"/>
+          </a:fillRef>
+          <a:effectRef idx="2">
+            <a:schemeClr val="accent1"/>
+          </a:effectRef>
+          <a:fontRef idx="minor">
+            <a:schemeClr val="lt1"/>
+          </a:fontRef>
+        </p:style>
+        <p:txBody>
+          <a:bodyPr rtlCol="0" anchor="ctr"/>
+          <a:lstStyle/>
+          <a:p>
+            <a:pPr algn="ctr"/>
+          </a:p>
+        </p:txBody>
+      </p:sp>
+      <p:sp>
+        <p:nvSpPr>
+          <p:cNvPr id="15" name="TextBox 14"/>
+          <p:cNvSpPr txBox="1"/>
+          <p:nvPr/>
+        </p:nvSpPr>
+        <p:spPr>
+          <a:xfrm>
+            <a:off x="3759200" y="2551429"/>
+            <a:ext cx="838200" cy="127000"/>
+          </a:xfrm>
+          <a:prstGeom prst="rect">
+            <a:avLst/>
+          </a:prstGeom>
+          <a:noFill/>
+        </p:spPr>
+        <p:txBody>
+          <a:bodyPr wrap="square" anchor="t" lIns="0" rIns="0" tIns="0" bIns="0">
+            <a:spAutoFit/>
+          </a:bodyPr>
+          <a:lstStyle/>
+          <a:p>
+            <a:pPr algn="r"/>
+            <a:r>
+              <a:rPr sz="700" b="0">
+                <a:solidFill>
+                  <a:srgbClr val="96BEEB"/>
+                </a:solidFill>
+                <a:latin typeface="Ubuntu Mono"/>
+              </a:rPr>
+              <a:t>3 000 m</a:t>
+            </a:r>
+          </a:p>
+        </p:txBody>
+      </p:sp>
       <p:pic>
         <p:nvPicPr>
-          <p:cNvPr id="5" name="Picture 4" descr="outil_SPX_bleu.png"/>
+          <p:cNvPr id="16" name="Picture 15" descr="logo-enedril-white.png"/>
           <p:cNvPicPr>
             <a:picLocks noChangeAspect="1"/>
           </p:cNvPicPr>
@@ -3299,30 +4045,6 @@
           </a:stretch>
         </p:blipFill>
         <p:spPr>
-          <a:xfrm rot="20160000">
-            <a:off x="-1206500" y="1333500"/>
-            <a:ext cx="7112000" cy="1295232"/>
-          </a:xfrm>
-          <a:prstGeom prst="rect">
-            <a:avLst/>
-          </a:prstGeom>
-        </p:spPr>
-      </p:pic>
-      <p:pic>
-        <p:nvPicPr>
-          <p:cNvPr id="6" name="Picture 5" descr="logo-enedril-white.png"/>
-          <p:cNvPicPr>
-            <a:picLocks noChangeAspect="1"/>
-          </p:cNvPicPr>
-          <p:nvPr/>
-        </p:nvPicPr>
-        <p:blipFill>
-          <a:blip r:embed="rId3"/>
-          <a:stretch>
-            <a:fillRect/>
-          </a:stretch>
-        </p:blipFill>
-        <p:spPr>
           <a:xfrm>
             <a:off x="355600" y="355600"/>
             <a:ext cx="1651000" cy="375658"/>
@@ -3334,7 +4056,7 @@
       </p:pic>
       <p:sp>
         <p:nvSpPr>
-          <p:cNvPr id="7" name="TextBox 6"/>
+          <p:cNvPr id="17" name="TextBox 16"/>
           <p:cNvSpPr txBox="1"/>
           <p:nvPr/>
         </p:nvSpPr>
@@ -3369,7 +4091,7 @@
       </p:sp>
       <p:sp>
         <p:nvSpPr>
-          <p:cNvPr id="8" name="TextBox 7"/>
+          <p:cNvPr id="18" name="TextBox 17"/>
           <p:cNvSpPr txBox="1"/>
           <p:nvPr/>
         </p:nvSpPr>
@@ -3404,7 +4126,7 @@
       </p:sp>
       <p:sp>
         <p:nvSpPr>
-          <p:cNvPr id="9" name="TextBox 8"/>
+          <p:cNvPr id="19" name="TextBox 18"/>
           <p:cNvSpPr txBox="1"/>
           <p:nvPr/>
         </p:nvSpPr>
@@ -3439,7 +4161,7 @@
       </p:sp>
       <p:sp>
         <p:nvSpPr>
-          <p:cNvPr id="10" name="TextBox 9"/>
+          <p:cNvPr id="20" name="TextBox 19"/>
           <p:cNvSpPr txBox="1"/>
           <p:nvPr/>
         </p:nvSpPr>
@@ -3478,7 +4200,7 @@
       </p:sp>
       <p:sp>
         <p:nvSpPr>
-          <p:cNvPr id="11" name="Freeform 10"/>
+          <p:cNvPr id="21" name="Freeform 20"/>
           <p:cNvSpPr/>
           <p:nvPr/>
         </p:nvSpPr>
@@ -3543,7 +4265,7 @@
       </p:sp>
       <p:sp>
         <p:nvSpPr>
-          <p:cNvPr id="12" name="TextBox 11"/>
+          <p:cNvPr id="22" name="TextBox 21"/>
           <p:cNvSpPr txBox="1"/>
           <p:nvPr/>
         </p:nvSpPr>
@@ -3578,7 +4300,7 @@
       </p:sp>
       <p:sp>
         <p:nvSpPr>
-          <p:cNvPr id="13" name="TextBox 12"/>
+          <p:cNvPr id="23" name="TextBox 22"/>
           <p:cNvSpPr txBox="1"/>
           <p:nvPr/>
         </p:nvSpPr>
@@ -3617,7 +4339,7 @@
       </p:sp>
       <p:sp>
         <p:nvSpPr>
-          <p:cNvPr id="14" name="Freeform 13"/>
+          <p:cNvPr id="24" name="Freeform 23"/>
           <p:cNvSpPr/>
           <p:nvPr/>
         </p:nvSpPr>
@@ -3682,7 +4404,7 @@
       </p:sp>
       <p:sp>
         <p:nvSpPr>
-          <p:cNvPr id="15" name="TextBox 14"/>
+          <p:cNvPr id="25" name="TextBox 24"/>
           <p:cNvSpPr txBox="1"/>
           <p:nvPr/>
         </p:nvSpPr>
@@ -3717,7 +4439,7 @@
       </p:sp>
       <p:sp>
         <p:nvSpPr>
-          <p:cNvPr id="16" name="TextBox 15"/>
+          <p:cNvPr id="26" name="TextBox 25"/>
           <p:cNvSpPr txBox="1"/>
           <p:nvPr/>
         </p:nvSpPr>
@@ -3756,7 +4478,7 @@
       </p:sp>
       <p:sp>
         <p:nvSpPr>
-          <p:cNvPr id="17" name="Freeform 16"/>
+          <p:cNvPr id="27" name="Freeform 26"/>
           <p:cNvSpPr/>
           <p:nvPr/>
         </p:nvSpPr>
@@ -3821,7 +4543,7 @@
       </p:sp>
       <p:sp>
         <p:nvSpPr>
-          <p:cNvPr id="18" name="TextBox 17"/>
+          <p:cNvPr id="28" name="TextBox 27"/>
           <p:cNvSpPr txBox="1"/>
           <p:nvPr/>
         </p:nvSpPr>
@@ -3856,7 +4578,7 @@
       </p:sp>
       <p:sp>
         <p:nvSpPr>
-          <p:cNvPr id="19" name="TextBox 18"/>
+          <p:cNvPr id="29" name="TextBox 28"/>
           <p:cNvSpPr txBox="1"/>
           <p:nvPr/>
         </p:nvSpPr>
@@ -3895,7 +4617,7 @@
       </p:sp>
       <p:sp>
         <p:nvSpPr>
-          <p:cNvPr id="20" name="Freeform 19"/>
+          <p:cNvPr id="30" name="Freeform 29"/>
           <p:cNvSpPr/>
           <p:nvPr/>
         </p:nvSpPr>
@@ -3960,7 +4682,7 @@
       </p:sp>
       <p:sp>
         <p:nvSpPr>
-          <p:cNvPr id="21" name="TextBox 20"/>
+          <p:cNvPr id="31" name="TextBox 30"/>
           <p:cNvSpPr txBox="1"/>
           <p:nvPr/>
         </p:nvSpPr>
@@ -3995,7 +4717,7 @@
       </p:sp>
       <p:sp>
         <p:nvSpPr>
-          <p:cNvPr id="22" name="TextBox 21"/>
+          <p:cNvPr id="32" name="TextBox 31"/>
           <p:cNvSpPr txBox="1"/>
           <p:nvPr/>
         </p:nvSpPr>
@@ -4034,7 +4756,7 @@
       </p:sp>
       <p:sp>
         <p:nvSpPr>
-          <p:cNvPr id="23" name="Freeform 22"/>
+          <p:cNvPr id="33" name="Freeform 32"/>
           <p:cNvSpPr/>
           <p:nvPr/>
         </p:nvSpPr>
@@ -4099,7 +4821,7 @@
       </p:sp>
       <p:sp>
         <p:nvSpPr>
-          <p:cNvPr id="24" name="TextBox 23"/>
+          <p:cNvPr id="34" name="TextBox 33"/>
           <p:cNvSpPr txBox="1"/>
           <p:nvPr/>
         </p:nvSpPr>
@@ -4134,7 +4856,7 @@
       </p:sp>
       <p:sp>
         <p:nvSpPr>
-          <p:cNvPr id="25" name="TextBox 24"/>
+          <p:cNvPr id="35" name="TextBox 34"/>
           <p:cNvSpPr txBox="1"/>
           <p:nvPr/>
         </p:nvSpPr>

</xml_diff>